<commit_message>
feat(pres): open on Feynman rather than a language quote
The deck previously opened on Mandela ("if you talk to a man in a language he
understands..."), which frames why the project exists but not what it did. The
benchmark is the substantial contribution, and its story is precisely the one
Feynman names: a confidence score that crowned an engine which had dropped the
"40", then a harness bug that declared a winner on a transcription never
generated. The hypothesis was reversed twice before it held.

Kept in English, in its original wording, with a French gloss underneath tying
it to those two findings and to the same rule inside the system -- no invented
data, no silent failure, a stock discrepancy reported rather than guessed.

Co-Authored-By: Claude Opus 5 <noreply@anthropic.com>
Claude-Session: https://claude.ai/code/session_0158GNu5iNvCmpeUmoLwMCUj
</commit_message>
<xml_diff>
--- a/Pres+report/Soutenance-PFE.pptx
+++ b/Pres+report/Soutenance-PFE.pptx
@@ -18903,8 +18903,8 @@
         </p:nvSpPr>
         <p:spPr>
           <a:xfrm>
-            <a:off x="868680" y="1965960"/>
-            <a:ext cx="45720" cy="2240280"/>
+            <a:off x="868680" y="1874519"/>
+            <a:ext cx="45720" cy="2057400"/>
           </a:xfrm>
           <a:prstGeom prst="rect">
             <a:avLst/>
@@ -18947,8 +18947,8 @@
         </p:nvSpPr>
         <p:spPr>
           <a:xfrm>
-            <a:off x="1463040" y="2011680"/>
-            <a:ext cx="9357055" cy="2194560"/>
+            <a:off x="1463040" y="1920240"/>
+            <a:ext cx="9357055" cy="2011680"/>
           </a:xfrm>
           <a:prstGeom prst="rect">
             <a:avLst/>
@@ -18967,31 +18967,31 @@
               </a:lnSpc>
             </a:pPr>
             <a:r>
-              <a:rPr sz="2500" b="0" i="0">
+              <a:rPr sz="2600" b="0" i="0">
                 <a:solidFill>
                   <a:srgbClr val="D5D5D5"/>
                 </a:solidFill>
                 <a:latin typeface="Arial"/>
               </a:rPr>
-              <a:t>« Si vous parlez à un homme dans une langue qu'il comprend, vous parlez à sa tête. </a:t>
-            </a:r>
-            <a:r>
-              <a:rPr sz="2500" b="1" i="0">
+              <a:t>“The first principle is that you must not fool yourself — </a:t>
+            </a:r>
+            <a:r>
+              <a:rPr sz="2600" b="1" i="0">
                 <a:solidFill>
                   <a:srgbClr val="FFFFFF"/>
                 </a:solidFill>
                 <a:latin typeface="Arial"/>
               </a:rPr>
-              <a:t>Si vous lui parlez dans sa langue, vous parlez à son cœur.</a:t>
-            </a:r>
-            <a:r>
-              <a:rPr sz="2500" b="0" i="0">
+              <a:t>and you are the easiest person to fool.</a:t>
+            </a:r>
+            <a:r>
+              <a:rPr sz="2600" b="0" i="0">
                 <a:solidFill>
                   <a:srgbClr val="D5D5D5"/>
                 </a:solidFill>
                 <a:latin typeface="Arial"/>
               </a:rPr>
-              <a:t> »</a:t>
+              <a:t>”</a:t>
             </a:r>
           </a:p>
         </p:txBody>
@@ -19004,7 +19004,7 @@
         </p:nvSpPr>
         <p:spPr>
           <a:xfrm>
-            <a:off x="1463040" y="4370832"/>
+            <a:off x="1463040" y="4078224"/>
             <a:ext cx="9357055" cy="292608"/>
           </a:xfrm>
           <a:prstGeom prst="rect">
@@ -19025,7 +19025,16 @@
                 </a:solidFill>
                 <a:latin typeface="Arial"/>
               </a:rPr>
-              <a:t>Nelson Mandela</a:t>
+              <a:t>Richard P. Feynman</a:t>
+            </a:r>
+            <a:r>
+              <a:rPr sz="1250" b="0" i="0">
+                <a:solidFill>
+                  <a:srgbClr val="7E7E7E"/>
+                </a:solidFill>
+                <a:latin typeface="Arial"/>
+              </a:rPr>
+              <a:t>   ·   Caltech, 1974</a:t>
             </a:r>
           </a:p>
         </p:txBody>
@@ -19038,8 +19047,8 @@
         </p:nvSpPr>
         <p:spPr>
           <a:xfrm>
-            <a:off x="1463040" y="4882896"/>
-            <a:ext cx="9357055" cy="822960"/>
+            <a:off x="1463040" y="4590288"/>
+            <a:ext cx="9357055" cy="1280160"/>
           </a:xfrm>
           <a:prstGeom prst="rect">
             <a:avLst/>
@@ -19054,17 +19063,53 @@
           <a:p>
             <a:pPr>
               <a:lnSpc>
-                <a:spcPct val="122000"/>
+                <a:spcPct val="124000"/>
               </a:lnSpc>
             </a:pPr>
             <a:r>
               <a:rPr sz="1400" b="0" i="0">
                 <a:solidFill>
-                  <a:srgbClr val="9C9C9C"/>
-                </a:solidFill>
-                <a:latin typeface="Arial"/>
-              </a:rPr>
-              <a:t>Le technicien de câblage pense, compte et raconte sa journée en darija. Tout le projet tient dans le refus de lui demander de se traduire lui-même : c'est au système de faire le trajet, pas à lui.</a:t>
+                  <a:srgbClr val="B8B8B8"/>
+                </a:solidFill>
+                <a:latin typeface="Arial"/>
+              </a:rPr>
+              <a:t>Le banc d'essai de ce projet s'est trompé deux fois avant de trancher : </a:t>
+            </a:r>
+            <a:r>
+              <a:rPr sz="1400" b="1" i="0">
+                <a:solidFill>
+                  <a:srgbClr val="E2E2E2"/>
+                </a:solidFill>
+                <a:latin typeface="Arial"/>
+              </a:rPr>
+              <a:t>un score de confiance qui couronnait un moteur ayant perdu le « 40 »</a:t>
+            </a:r>
+            <a:r>
+              <a:rPr sz="1400" b="0" i="0">
+                <a:solidFill>
+                  <a:srgbClr val="B8B8B8"/>
+                </a:solidFill>
+                <a:latin typeface="Arial"/>
+              </a:rPr>
+              <a:t>, puis </a:t>
+            </a:r>
+            <a:r>
+              <a:rPr sz="1400" b="1" i="0">
+                <a:solidFill>
+                  <a:srgbClr val="E2E2E2"/>
+                </a:solidFill>
+                <a:latin typeface="Arial"/>
+              </a:rPr>
+              <a:t>un bogue de harnais qui désignait un vainqueur sur une transcription jamais produite</a:t>
+            </a:r>
+            <a:r>
+              <a:rPr sz="1400" b="0" i="0">
+                <a:solidFill>
+                  <a:srgbClr val="B8B8B8"/>
+                </a:solidFill>
+                <a:latin typeface="Arial"/>
+              </a:rPr>
+              <a:t>. La même exigence gouverne le système lui-même : aucune donnée inventée, aucun échec silencieux, et un écart de stock signalé plutôt que deviné.</a:t>
             </a:r>
           </a:p>
         </p:txBody>

</xml_diff>

<commit_message>
feat(pres): use the supplied artwork for the Wittgenstein slide
Replaces the typeset version with assets/quote-wittgenstein.png, placed full
bleed. The image is 1672x941, exactly 16:9, so it fills the slide without
letterboxing or a crop; a build-time assertion checks that ratio rather than
trusting it, since a replacement asset at another aspect would otherwise be
stretched silently.

No footer and no caption on this slide. The artwork already carries the quote
and the attribution, a page number laid over parchment reads as an accident,
and the tie back to the project is spoken rather than printed.

Drops the Georgia constant and the font/track arguments added for the typeset
version -- with the artwork in place they have no call sites.

Co-Authored-By: Claude Opus 5 <noreply@anthropic.com>
Claude-Session: https://claude.ai/code/session_0158GNu5iNvCmpeUmoLwMCUj
</commit_message>
<xml_diff>
--- a/Pres+report/Soutenance-PFE.pptx
+++ b/Pres+report/Soutenance-PFE.pptx
@@ -18795,7 +18795,7 @@
     <p:bg>
       <p:bgPr>
         <a:solidFill>
-          <a:srgbClr val="1C1F23"/>
+          <a:srgbClr val="FFFFFF"/>
         </a:solidFill>
         <a:effectLst/>
       </p:bgPr>
@@ -18807,415 +18807,30 @@
         <p:nvPr/>
       </p:nvGrpSpPr>
       <p:grpSpPr/>
-      <p:sp>
-        <p:nvSpPr>
-          <p:cNvPr id="2" name="Rectangle 1"/>
-          <p:cNvSpPr/>
-          <p:nvPr/>
-        </p:nvSpPr>
+      <p:pic>
+        <p:nvPicPr>
+          <p:cNvPr id="2" name="Picture 1" descr="quote-wittgenstein.png"/>
+          <p:cNvPicPr>
+            <a:picLocks noChangeAspect="1"/>
+          </p:cNvPicPr>
+          <p:nvPr/>
+        </p:nvPicPr>
+        <p:blipFill>
+          <a:blip r:embed="rId2"/>
+          <a:stretch>
+            <a:fillRect/>
+          </a:stretch>
+        </p:blipFill>
         <p:spPr>
           <a:xfrm>
             <a:off x="0" y="0"/>
-            <a:ext cx="12191695" cy="91440"/>
-          </a:xfrm>
-          <a:prstGeom prst="rect">
-            <a:avLst/>
-          </a:prstGeom>
-          <a:solidFill>
-            <a:srgbClr val="0B8E36"/>
-          </a:solidFill>
-          <a:ln>
-            <a:noFill/>
-          </a:ln>
-          <a:effectLst/>
-        </p:spPr>
-        <p:style>
-          <a:lnRef idx="1">
-            <a:schemeClr val="accent1"/>
-          </a:lnRef>
-          <a:fillRef idx="3">
-            <a:schemeClr val="accent1"/>
-          </a:fillRef>
-          <a:effectRef idx="2">
-            <a:schemeClr val="accent1"/>
-          </a:effectRef>
-          <a:fontRef idx="minor">
-            <a:schemeClr val="lt1"/>
-          </a:fontRef>
-        </p:style>
-        <p:txBody>
-          <a:bodyPr rtlCol="0" anchor="ctr" wrap="square"/>
-          <a:lstStyle/>
-          <a:p>
-            <a:pPr algn="ctr"/>
-          </a:p>
-        </p:txBody>
-      </p:sp>
-      <p:sp>
-        <p:nvSpPr>
-          <p:cNvPr id="3" name="Rectangle 2"/>
-          <p:cNvSpPr/>
-          <p:nvPr/>
-        </p:nvSpPr>
-        <p:spPr>
-          <a:xfrm>
-            <a:off x="0" y="6766560"/>
-            <a:ext cx="12191695" cy="91440"/>
-          </a:xfrm>
-          <a:prstGeom prst="rect">
-            <a:avLst/>
-          </a:prstGeom>
-          <a:solidFill>
-            <a:srgbClr val="0278E4"/>
-          </a:solidFill>
-          <a:ln>
-            <a:noFill/>
-          </a:ln>
-          <a:effectLst/>
-        </p:spPr>
-        <p:style>
-          <a:lnRef idx="1">
-            <a:schemeClr val="accent1"/>
-          </a:lnRef>
-          <a:fillRef idx="3">
-            <a:schemeClr val="accent1"/>
-          </a:fillRef>
-          <a:effectRef idx="2">
-            <a:schemeClr val="accent1"/>
-          </a:effectRef>
-          <a:fontRef idx="minor">
-            <a:schemeClr val="lt1"/>
-          </a:fontRef>
-        </p:style>
-        <p:txBody>
-          <a:bodyPr rtlCol="0" anchor="ctr" wrap="square"/>
-          <a:lstStyle/>
-          <a:p>
-            <a:pPr algn="ctr"/>
-          </a:p>
-        </p:txBody>
-      </p:sp>
-      <p:sp>
-        <p:nvSpPr>
-          <p:cNvPr id="4" name="TextBox 3"/>
-          <p:cNvSpPr txBox="1"/>
-          <p:nvPr/>
-        </p:nvSpPr>
-        <p:spPr>
-          <a:xfrm>
-            <a:off x="502920" y="960120"/>
-            <a:ext cx="2743200" cy="2743200"/>
-          </a:xfrm>
-          <a:prstGeom prst="rect">
-            <a:avLst/>
-          </a:prstGeom>
-          <a:noFill/>
-        </p:spPr>
-        <p:txBody>
-          <a:bodyPr wrap="square" lIns="0" rIns="0" tIns="0" bIns="0">
-            <a:spAutoFit/>
-          </a:bodyPr>
-          <a:lstStyle/>
-          <a:p>
-            <a:r>
-              <a:rPr sz="20000" b="1" i="0">
-                <a:solidFill>
-                  <a:srgbClr val="2B3138"/>
-                </a:solidFill>
-                <a:latin typeface="Georgia"/>
-              </a:rPr>
-              <a:t>“</a:t>
-            </a:r>
-          </a:p>
-        </p:txBody>
-      </p:sp>
-      <p:sp>
-        <p:nvSpPr>
-          <p:cNvPr id="5" name="TextBox 4"/>
-          <p:cNvSpPr txBox="1"/>
-          <p:nvPr/>
-        </p:nvSpPr>
-        <p:spPr>
-          <a:xfrm>
-            <a:off x="1645919" y="2029968"/>
-            <a:ext cx="9174175" cy="2286000"/>
-          </a:xfrm>
-          <a:prstGeom prst="rect">
-            <a:avLst/>
-          </a:prstGeom>
-          <a:noFill/>
-        </p:spPr>
-        <p:txBody>
-          <a:bodyPr wrap="square" lIns="0" rIns="0" tIns="0" bIns="0">
-            <a:spAutoFit/>
-          </a:bodyPr>
-          <a:lstStyle/>
-          <a:p>
-            <a:pPr>
-              <a:lnSpc>
-                <a:spcPct val="116000"/>
-              </a:lnSpc>
-            </a:pPr>
-            <a:r>
-              <a:rPr sz="4200" b="0" i="0">
-                <a:solidFill>
-                  <a:srgbClr val="9AA2AB"/>
-                </a:solidFill>
-                <a:latin typeface="Georgia"/>
-              </a:rPr>
-              <a:t>The limits of my language
-</a:t>
-            </a:r>
-            <a:r>
-              <a:rPr sz="4200" b="1" i="0">
-                <a:solidFill>
-                  <a:srgbClr val="FFFFFF"/>
-                </a:solidFill>
-                <a:latin typeface="Georgia"/>
-              </a:rPr>
-              <a:t>mean the limits of my world.</a:t>
-            </a:r>
-          </a:p>
-        </p:txBody>
-      </p:sp>
-      <p:sp>
-        <p:nvSpPr>
-          <p:cNvPr id="6" name="Rectangle 5"/>
-          <p:cNvSpPr/>
-          <p:nvPr/>
-        </p:nvSpPr>
-        <p:spPr>
-          <a:xfrm>
-            <a:off x="1673352" y="4297680"/>
-            <a:ext cx="777240" cy="27432"/>
-          </a:xfrm>
-          <a:prstGeom prst="rect">
-            <a:avLst/>
-          </a:prstGeom>
-          <a:solidFill>
-            <a:srgbClr val="0278E4"/>
-          </a:solidFill>
-          <a:ln>
-            <a:noFill/>
-          </a:ln>
-          <a:effectLst/>
-        </p:spPr>
-        <p:style>
-          <a:lnRef idx="1">
-            <a:schemeClr val="accent1"/>
-          </a:lnRef>
-          <a:fillRef idx="3">
-            <a:schemeClr val="accent1"/>
-          </a:fillRef>
-          <a:effectRef idx="2">
-            <a:schemeClr val="accent1"/>
-          </a:effectRef>
-          <a:fontRef idx="minor">
-            <a:schemeClr val="lt1"/>
-          </a:fontRef>
-        </p:style>
-        <p:txBody>
-          <a:bodyPr rtlCol="0" anchor="ctr" wrap="square"/>
-          <a:lstStyle/>
-          <a:p>
-            <a:pPr algn="ctr"/>
-          </a:p>
-        </p:txBody>
-      </p:sp>
-      <p:sp>
-        <p:nvSpPr>
-          <p:cNvPr id="7" name="TextBox 6"/>
-          <p:cNvSpPr txBox="1"/>
-          <p:nvPr/>
-        </p:nvSpPr>
-        <p:spPr>
-          <a:xfrm>
-            <a:off x="1673352" y="4553712"/>
-            <a:ext cx="9174175" cy="274320"/>
-          </a:xfrm>
-          <a:prstGeom prst="rect">
-            <a:avLst/>
-          </a:prstGeom>
-          <a:noFill/>
-        </p:spPr>
-        <p:txBody>
-          <a:bodyPr wrap="square" lIns="0" rIns="0" tIns="0" bIns="0">
-            <a:spAutoFit/>
-          </a:bodyPr>
-          <a:lstStyle/>
-          <a:p>
-            <a:r>
-              <a:rPr sz="1200" b="1" i="0" spc="220">
-                <a:solidFill>
-                  <a:srgbClr val="5CB0F7"/>
-                </a:solidFill>
-                <a:latin typeface="Arial"/>
-              </a:rPr>
-              <a:t>LUDWIG WITTGENSTEIN</a:t>
-            </a:r>
-          </a:p>
-        </p:txBody>
-      </p:sp>
-      <p:sp>
-        <p:nvSpPr>
-          <p:cNvPr id="8" name="TextBox 7"/>
-          <p:cNvSpPr txBox="1"/>
-          <p:nvPr/>
-        </p:nvSpPr>
-        <p:spPr>
-          <a:xfrm>
-            <a:off x="1673352" y="4846320"/>
-            <a:ext cx="9174175" cy="274320"/>
-          </a:xfrm>
-          <a:prstGeom prst="rect">
-            <a:avLst/>
-          </a:prstGeom>
-          <a:noFill/>
-        </p:spPr>
-        <p:txBody>
-          <a:bodyPr wrap="square" lIns="0" rIns="0" tIns="0" bIns="0">
-            <a:spAutoFit/>
-          </a:bodyPr>
-          <a:lstStyle/>
-          <a:p>
-            <a:r>
-              <a:rPr sz="1200" b="0" i="1">
-                <a:solidFill>
-                  <a:srgbClr val="767C84"/>
-                </a:solidFill>
-                <a:latin typeface="Georgia"/>
-              </a:rPr>
-              <a:t>Tractatus Logico-Philosophicus, §5.6 — 1921</a:t>
-            </a:r>
-          </a:p>
-        </p:txBody>
-      </p:sp>
-      <p:sp>
-        <p:nvSpPr>
-          <p:cNvPr id="9" name="TextBox 8"/>
-          <p:cNvSpPr txBox="1"/>
-          <p:nvPr/>
-        </p:nvSpPr>
-        <p:spPr>
-          <a:xfrm>
-            <a:off x="1673352" y="5413248"/>
-            <a:ext cx="8442655" cy="822960"/>
-          </a:xfrm>
-          <a:prstGeom prst="rect">
-            <a:avLst/>
-          </a:prstGeom>
-          <a:noFill/>
-        </p:spPr>
-        <p:txBody>
-          <a:bodyPr wrap="square" lIns="0" rIns="0" tIns="0" bIns="0">
-            <a:spAutoFit/>
-          </a:bodyPr>
-          <a:lstStyle/>
-          <a:p>
-            <a:pPr>
-              <a:lnSpc>
-                <a:spcPct val="126000"/>
-              </a:lnSpc>
-            </a:pPr>
-            <a:r>
-              <a:rPr sz="1350" b="0" i="0">
-                <a:solidFill>
-                  <a:srgbClr val="8E959C"/>
-                </a:solidFill>
-                <a:latin typeface="Arial"/>
-              </a:rPr>
-              <a:t>Le technicien de câblage pense, compte et raconte sa journée en darija. </a:t>
-            </a:r>
-            <a:r>
-              <a:rPr sz="1350" b="1" i="0">
-                <a:solidFill>
-                  <a:srgbClr val="D3D8DD"/>
-                </a:solidFill>
-                <a:latin typeface="Arial"/>
-              </a:rPr>
-              <a:t>Lui demander un rapport en français, c'est rétrécir ce qu'il peut dire.</a:t>
-            </a:r>
-            <a:r>
-              <a:rPr sz="1350" b="0" i="0">
-                <a:solidFill>
-                  <a:srgbClr val="8E959C"/>
-                </a:solidFill>
-                <a:latin typeface="Arial"/>
-              </a:rPr>
-              <a:t> Tout le projet tient dans le refus de lui faire faire ce trajet.</a:t>
-            </a:r>
-          </a:p>
-        </p:txBody>
-      </p:sp>
-      <p:sp>
-        <p:nvSpPr>
-          <p:cNvPr id="10" name="TextBox 9"/>
-          <p:cNvSpPr txBox="1"/>
-          <p:nvPr/>
-        </p:nvSpPr>
-        <p:spPr>
-          <a:xfrm>
-            <a:off x="777240" y="6327648"/>
-            <a:ext cx="10088575" cy="201168"/>
-          </a:xfrm>
-          <a:prstGeom prst="rect">
-            <a:avLst/>
-          </a:prstGeom>
-          <a:noFill/>
-        </p:spPr>
-        <p:txBody>
-          <a:bodyPr wrap="square" lIns="0" rIns="0" tIns="0" bIns="0">
-            <a:spAutoFit/>
-          </a:bodyPr>
-          <a:lstStyle/>
-          <a:p>
-            <a:r>
-              <a:rPr sz="850" b="0" i="0">
-                <a:solidFill>
-                  <a:srgbClr val="9A9A9A"/>
-                </a:solidFill>
-                <a:latin typeface="Arial"/>
-              </a:rPr>
-              <a:t>AZnet — Automatisation des rapports journaliers de chantier par IA</a:t>
-            </a:r>
-          </a:p>
-        </p:txBody>
-      </p:sp>
-      <p:sp>
-        <p:nvSpPr>
-          <p:cNvPr id="11" name="TextBox 10"/>
-          <p:cNvSpPr txBox="1"/>
-          <p:nvPr/>
-        </p:nvSpPr>
-        <p:spPr>
-          <a:xfrm>
-            <a:off x="10865815" y="6327648"/>
-            <a:ext cx="548640" cy="201168"/>
-          </a:xfrm>
-          <a:prstGeom prst="rect">
-            <a:avLst/>
-          </a:prstGeom>
-          <a:noFill/>
-        </p:spPr>
-        <p:txBody>
-          <a:bodyPr wrap="square" lIns="0" rIns="0" tIns="0" bIns="0">
-            <a:spAutoFit/>
-          </a:bodyPr>
-          <a:lstStyle/>
-          <a:p>
-            <a:pPr algn="r"/>
-            <a:r>
-              <a:rPr sz="850" b="1" i="0">
-                <a:solidFill>
-                  <a:srgbClr val="9A9A9A"/>
-                </a:solidFill>
-                <a:latin typeface="Arial"/>
-              </a:rPr>
-              <a:t>3</a:t>
-            </a:r>
-          </a:p>
-        </p:txBody>
-      </p:sp>
+            <a:ext cx="12191695" cy="6858000"/>
+          </a:xfrm>
+          <a:prstGeom prst="rect">
+            <a:avLst/>
+          </a:prstGeom>
+        </p:spPr>
+      </p:pic>
     </p:spTree>
   </p:cSld>
   <p:clrMapOvr>

</xml_diff>